<commit_message>
included figure of a system now removed (hpc: w3/bilayer_data/TBT-*, the first calculations)
</commit_message>
<xml_diff>
--- a/meeting_notes/presentation.pptx
+++ b/meeting_notes/presentation.pptx
@@ -33,13 +33,14 @@
     <p:sldId id="309" r:id="rId27"/>
     <p:sldId id="311" r:id="rId28"/>
     <p:sldId id="312" r:id="rId29"/>
-    <p:sldId id="282" r:id="rId30"/>
-    <p:sldId id="277" r:id="rId31"/>
-    <p:sldId id="283" r:id="rId32"/>
-    <p:sldId id="278" r:id="rId33"/>
-    <p:sldId id="280" r:id="rId34"/>
-    <p:sldId id="279" r:id="rId35"/>
-    <p:sldId id="281" r:id="rId36"/>
+    <p:sldId id="313" r:id="rId30"/>
+    <p:sldId id="282" r:id="rId31"/>
+    <p:sldId id="277" r:id="rId32"/>
+    <p:sldId id="283" r:id="rId33"/>
+    <p:sldId id="278" r:id="rId34"/>
+    <p:sldId id="280" r:id="rId35"/>
+    <p:sldId id="279" r:id="rId36"/>
+    <p:sldId id="281" r:id="rId37"/>
   </p:sldIdLst>
   <p:sldSz cx="9144000" cy="6858000" type="screen4x3"/>
   <p:notesSz cx="6858000" cy="9144000"/>
@@ -336,7 +337,7 @@
           <a:p>
             <a:fld id="{241EB5C9-1307-BA42-ABA2-0BC069CD8E7F}" type="datetimeFigureOut">
               <a:rPr lang="en-US" smtClean="0"/>
-              <a:t>3/15/2026</a:t>
+              <a:t>6/14/2026</a:t>
             </a:fld>
             <a:endParaRPr lang="en-US"/>
           </a:p>
@@ -504,7 +505,7 @@
           <a:p>
             <a:fld id="{241EB5C9-1307-BA42-ABA2-0BC069CD8E7F}" type="datetimeFigureOut">
               <a:rPr lang="en-US" smtClean="0"/>
-              <a:t>3/15/2026</a:t>
+              <a:t>6/14/2026</a:t>
             </a:fld>
             <a:endParaRPr lang="en-US"/>
           </a:p>
@@ -682,7 +683,7 @@
           <a:p>
             <a:fld id="{241EB5C9-1307-BA42-ABA2-0BC069CD8E7F}" type="datetimeFigureOut">
               <a:rPr lang="en-US" smtClean="0"/>
-              <a:t>3/15/2026</a:t>
+              <a:t>6/14/2026</a:t>
             </a:fld>
             <a:endParaRPr lang="en-US"/>
           </a:p>
@@ -850,7 +851,7 @@
           <a:p>
             <a:fld id="{241EB5C9-1307-BA42-ABA2-0BC069CD8E7F}" type="datetimeFigureOut">
               <a:rPr lang="en-US" smtClean="0"/>
-              <a:t>3/15/2026</a:t>
+              <a:t>6/14/2026</a:t>
             </a:fld>
             <a:endParaRPr lang="en-US"/>
           </a:p>
@@ -1095,7 +1096,7 @@
           <a:p>
             <a:fld id="{241EB5C9-1307-BA42-ABA2-0BC069CD8E7F}" type="datetimeFigureOut">
               <a:rPr lang="en-US" smtClean="0"/>
-              <a:t>3/15/2026</a:t>
+              <a:t>6/14/2026</a:t>
             </a:fld>
             <a:endParaRPr lang="en-US"/>
           </a:p>
@@ -1380,7 +1381,7 @@
           <a:p>
             <a:fld id="{241EB5C9-1307-BA42-ABA2-0BC069CD8E7F}" type="datetimeFigureOut">
               <a:rPr lang="en-US" smtClean="0"/>
-              <a:t>3/15/2026</a:t>
+              <a:t>6/14/2026</a:t>
             </a:fld>
             <a:endParaRPr lang="en-US"/>
           </a:p>
@@ -1799,7 +1800,7 @@
           <a:p>
             <a:fld id="{241EB5C9-1307-BA42-ABA2-0BC069CD8E7F}" type="datetimeFigureOut">
               <a:rPr lang="en-US" smtClean="0"/>
-              <a:t>3/15/2026</a:t>
+              <a:t>6/14/2026</a:t>
             </a:fld>
             <a:endParaRPr lang="en-US"/>
           </a:p>
@@ -1916,7 +1917,7 @@
           <a:p>
             <a:fld id="{241EB5C9-1307-BA42-ABA2-0BC069CD8E7F}" type="datetimeFigureOut">
               <a:rPr lang="en-US" smtClean="0"/>
-              <a:t>3/15/2026</a:t>
+              <a:t>6/14/2026</a:t>
             </a:fld>
             <a:endParaRPr lang="en-US"/>
           </a:p>
@@ -2011,7 +2012,7 @@
           <a:p>
             <a:fld id="{241EB5C9-1307-BA42-ABA2-0BC069CD8E7F}" type="datetimeFigureOut">
               <a:rPr lang="en-US" smtClean="0"/>
-              <a:t>3/15/2026</a:t>
+              <a:t>6/14/2026</a:t>
             </a:fld>
             <a:endParaRPr lang="en-US"/>
           </a:p>
@@ -2286,7 +2287,7 @@
           <a:p>
             <a:fld id="{241EB5C9-1307-BA42-ABA2-0BC069CD8E7F}" type="datetimeFigureOut">
               <a:rPr lang="en-US" smtClean="0"/>
-              <a:t>3/15/2026</a:t>
+              <a:t>6/14/2026</a:t>
             </a:fld>
             <a:endParaRPr lang="en-US"/>
           </a:p>
@@ -2538,7 +2539,7 @@
           <a:p>
             <a:fld id="{241EB5C9-1307-BA42-ABA2-0BC069CD8E7F}" type="datetimeFigureOut">
               <a:rPr lang="en-US" smtClean="0"/>
-              <a:t>3/15/2026</a:t>
+              <a:t>6/14/2026</a:t>
             </a:fld>
             <a:endParaRPr lang="en-US"/>
           </a:p>
@@ -2749,7 +2750,7 @@
           <a:p>
             <a:fld id="{241EB5C9-1307-BA42-ABA2-0BC069CD8E7F}" type="datetimeFigureOut">
               <a:rPr lang="en-US" smtClean="0"/>
-              <a:t>3/15/2026</a:t>
+              <a:t>6/14/2026</a:t>
             </a:fld>
             <a:endParaRPr lang="en-US"/>
           </a:p>
@@ -7440,7 +7441,7 @@
 </file>
 
 <file path=ppt/slides/slide29.xml><?xml version="1.0" encoding="utf-8"?>
-<p:sld xmlns:a="http://schemas.openxmlformats.org/drawingml/2006/main" xmlns:r="http://schemas.openxmlformats.org/officeDocument/2006/relationships" xmlns:p="http://schemas.openxmlformats.org/presentationml/2006/main" show="0">
+<p:sld xmlns:a="http://schemas.openxmlformats.org/drawingml/2006/main" xmlns:r="http://schemas.openxmlformats.org/officeDocument/2006/relationships" xmlns:p="http://schemas.openxmlformats.org/presentationml/2006/main">
   <p:cSld>
     <p:spTree>
       <p:nvGrpSpPr>
@@ -7458,18 +7459,18 @@
       </p:grpSpPr>
       <p:sp>
         <p:nvSpPr>
-          <p:cNvPr id="7" name="Title 6">
-            <a:extLst>
-              <a:ext uri="{FF2B5EF4-FFF2-40B4-BE49-F238E27FC236}">
-                <a16:creationId xmlns:a16="http://schemas.microsoft.com/office/drawing/2014/main" id="{442990F7-FDA5-0C94-A608-69F719BA7ADF}"/>
-              </a:ext>
-            </a:extLst>
-          </p:cNvPr>
-          <p:cNvSpPr>
-            <a:spLocks noGrp="1"/>
-          </p:cNvSpPr>
-          <p:nvPr>
-            <p:ph type="ctrTitle"/>
+          <p:cNvPr id="2" name="Title 1">
+            <a:extLst>
+              <a:ext uri="{FF2B5EF4-FFF2-40B4-BE49-F238E27FC236}">
+                <a16:creationId xmlns:a16="http://schemas.microsoft.com/office/drawing/2014/main" id="{AC5EB0AB-1723-75F9-43CE-D3DED6A990DF}"/>
+              </a:ext>
+            </a:extLst>
+          </p:cNvPr>
+          <p:cNvSpPr>
+            <a:spLocks noGrp="1"/>
+          </p:cNvSpPr>
+          <p:nvPr>
+            <p:ph type="title"/>
           </p:nvPr>
         </p:nvSpPr>
         <p:spPr/>
@@ -7478,41 +7479,151 @@
           <a:lstStyle/>
           <a:p>
             <a:r>
-              <a:rPr lang="en-US" dirty="0"/>
-              <a:t>RSE for armchair + zigzag</a:t>
-            </a:r>
-          </a:p>
-        </p:txBody>
-      </p:sp>
-      <p:sp>
-        <p:nvSpPr>
-          <p:cNvPr id="8" name="Subtitle 7">
-            <a:extLst>
-              <a:ext uri="{FF2B5EF4-FFF2-40B4-BE49-F238E27FC236}">
-                <a16:creationId xmlns:a16="http://schemas.microsoft.com/office/drawing/2014/main" id="{591C8F23-4878-D975-ED4B-AB5584C19A7F}"/>
-              </a:ext>
-            </a:extLst>
-          </p:cNvPr>
-          <p:cNvSpPr>
-            <a:spLocks noGrp="1"/>
-          </p:cNvSpPr>
-          <p:nvPr>
-            <p:ph type="subTitle" idx="1"/>
+              <a:rPr lang="da-DK" dirty="0"/>
+              <a:t>Now </a:t>
+            </a:r>
+            <a:r>
+              <a:rPr lang="da-DK" dirty="0" err="1"/>
+              <a:t>deleted</a:t>
+            </a:r>
+            <a:r>
+              <a:rPr lang="da-DK" dirty="0"/>
+              <a:t> data</a:t>
+            </a:r>
+          </a:p>
+        </p:txBody>
+      </p:sp>
+      <p:sp>
+        <p:nvSpPr>
+          <p:cNvPr id="3" name="Text Placeholder 2">
+            <a:extLst>
+              <a:ext uri="{FF2B5EF4-FFF2-40B4-BE49-F238E27FC236}">
+                <a16:creationId xmlns:a16="http://schemas.microsoft.com/office/drawing/2014/main" id="{06F32478-5AB2-1527-82F6-7F5DA087C046}"/>
+              </a:ext>
+            </a:extLst>
+          </p:cNvPr>
+          <p:cNvSpPr>
+            <a:spLocks noGrp="1"/>
+          </p:cNvSpPr>
+          <p:nvPr>
+            <p:ph type="body" idx="1"/>
           </p:nvPr>
         </p:nvSpPr>
         <p:spPr/>
         <p:txBody>
-          <a:bodyPr/>
-          <a:lstStyle/>
-          <a:p>
-            <a:endParaRPr lang="en-US"/>
+          <a:bodyPr>
+            <a:normAutofit fontScale="92500"/>
+          </a:bodyPr>
+          <a:lstStyle/>
+          <a:p>
+            <a:r>
+              <a:rPr lang="da-DK" dirty="0"/>
+              <a:t>NC=1 angle=0 </a:t>
+            </a:r>
+            <a:r>
+              <a:rPr lang="da-DK" dirty="0" err="1"/>
+              <a:t>deg</a:t>
+            </a:r>
+            <a:r>
+              <a:rPr lang="da-DK" dirty="0"/>
+              <a:t>. R/2 -&gt; R </a:t>
+            </a:r>
+            <a:r>
+              <a:rPr lang="da-DK" dirty="0" err="1"/>
+              <a:t>layer</a:t>
+            </a:r>
+            <a:endParaRPr lang="da-DK" dirty="0"/>
+          </a:p>
+        </p:txBody>
+      </p:sp>
+      <p:pic>
+        <p:nvPicPr>
+          <p:cNvPr id="8" name="Content Placeholder 7">
+            <a:extLst>
+              <a:ext uri="{FF2B5EF4-FFF2-40B4-BE49-F238E27FC236}">
+                <a16:creationId xmlns:a16="http://schemas.microsoft.com/office/drawing/2014/main" id="{EBABB826-DD3A-9E30-7E31-58FD8DFB6CE9}"/>
+              </a:ext>
+            </a:extLst>
+          </p:cNvPr>
+          <p:cNvPicPr>
+            <a:picLocks noGrp="1" noChangeAspect="1"/>
+          </p:cNvPicPr>
+          <p:nvPr>
+            <p:ph sz="half" idx="2"/>
+          </p:nvPr>
+        </p:nvPicPr>
+        <p:blipFill>
+          <a:blip r:embed="rId2"/>
+          <a:stretch>
+            <a:fillRect/>
+          </a:stretch>
+        </p:blipFill>
+        <p:spPr>
+          <a:xfrm>
+            <a:off x="457200" y="2452366"/>
+            <a:ext cx="4040188" cy="3396305"/>
+          </a:xfrm>
+          <a:prstGeom prst="rect">
+            <a:avLst/>
+          </a:prstGeom>
+        </p:spPr>
+      </p:pic>
+      <p:sp>
+        <p:nvSpPr>
+          <p:cNvPr id="5" name="Text Placeholder 4">
+            <a:extLst>
+              <a:ext uri="{FF2B5EF4-FFF2-40B4-BE49-F238E27FC236}">
+                <a16:creationId xmlns:a16="http://schemas.microsoft.com/office/drawing/2014/main" id="{D234D8A1-83D6-349B-3025-49C806E4205A}"/>
+              </a:ext>
+            </a:extLst>
+          </p:cNvPr>
+          <p:cNvSpPr>
+            <a:spLocks noGrp="1"/>
+          </p:cNvSpPr>
+          <p:nvPr>
+            <p:ph type="body" sz="quarter" idx="3"/>
+          </p:nvPr>
+        </p:nvSpPr>
+        <p:spPr/>
+        <p:txBody>
+          <a:bodyPr>
+            <a:normAutofit fontScale="92500"/>
+          </a:bodyPr>
+          <a:lstStyle/>
+          <a:p>
+            <a:endParaRPr lang="da-DK"/>
+          </a:p>
+        </p:txBody>
+      </p:sp>
+      <p:sp>
+        <p:nvSpPr>
+          <p:cNvPr id="6" name="Content Placeholder 5">
+            <a:extLst>
+              <a:ext uri="{FF2B5EF4-FFF2-40B4-BE49-F238E27FC236}">
+                <a16:creationId xmlns:a16="http://schemas.microsoft.com/office/drawing/2014/main" id="{05FC30D8-2D87-A04E-DB63-F47BF4BF46CD}"/>
+              </a:ext>
+            </a:extLst>
+          </p:cNvPr>
+          <p:cNvSpPr>
+            <a:spLocks noGrp="1"/>
+          </p:cNvSpPr>
+          <p:nvPr>
+            <p:ph sz="quarter" idx="4"/>
+          </p:nvPr>
+        </p:nvSpPr>
+        <p:spPr/>
+        <p:txBody>
+          <a:bodyPr/>
+          <a:lstStyle/>
+          <a:p>
+            <a:endParaRPr lang="da-DK"/>
           </a:p>
         </p:txBody>
       </p:sp>
     </p:spTree>
     <p:extLst>
       <p:ext uri="{BB962C8B-B14F-4D97-AF65-F5344CB8AC3E}">
-        <p14:creationId xmlns:p14="http://schemas.microsoft.com/office/powerpoint/2010/main" val="2544406285"/>
+        <p14:creationId xmlns:p14="http://schemas.microsoft.com/office/powerpoint/2010/main" val="2634661432"/>
       </p:ext>
     </p:extLst>
   </p:cSld>
@@ -7634,6 +7745,89 @@
       </p:grpSpPr>
       <p:sp>
         <p:nvSpPr>
+          <p:cNvPr id="7" name="Title 6">
+            <a:extLst>
+              <a:ext uri="{FF2B5EF4-FFF2-40B4-BE49-F238E27FC236}">
+                <a16:creationId xmlns:a16="http://schemas.microsoft.com/office/drawing/2014/main" id="{442990F7-FDA5-0C94-A608-69F719BA7ADF}"/>
+              </a:ext>
+            </a:extLst>
+          </p:cNvPr>
+          <p:cNvSpPr>
+            <a:spLocks noGrp="1"/>
+          </p:cNvSpPr>
+          <p:nvPr>
+            <p:ph type="ctrTitle"/>
+          </p:nvPr>
+        </p:nvSpPr>
+        <p:spPr/>
+        <p:txBody>
+          <a:bodyPr/>
+          <a:lstStyle/>
+          <a:p>
+            <a:r>
+              <a:rPr lang="en-US" dirty="0"/>
+              <a:t>RSE for armchair + zigzag</a:t>
+            </a:r>
+          </a:p>
+        </p:txBody>
+      </p:sp>
+      <p:sp>
+        <p:nvSpPr>
+          <p:cNvPr id="8" name="Subtitle 7">
+            <a:extLst>
+              <a:ext uri="{FF2B5EF4-FFF2-40B4-BE49-F238E27FC236}">
+                <a16:creationId xmlns:a16="http://schemas.microsoft.com/office/drawing/2014/main" id="{591C8F23-4878-D975-ED4B-AB5584C19A7F}"/>
+              </a:ext>
+            </a:extLst>
+          </p:cNvPr>
+          <p:cNvSpPr>
+            <a:spLocks noGrp="1"/>
+          </p:cNvSpPr>
+          <p:nvPr>
+            <p:ph type="subTitle" idx="1"/>
+          </p:nvPr>
+        </p:nvSpPr>
+        <p:spPr/>
+        <p:txBody>
+          <a:bodyPr/>
+          <a:lstStyle/>
+          <a:p>
+            <a:endParaRPr lang="en-US"/>
+          </a:p>
+        </p:txBody>
+      </p:sp>
+    </p:spTree>
+    <p:extLst>
+      <p:ext uri="{BB962C8B-B14F-4D97-AF65-F5344CB8AC3E}">
+        <p14:creationId xmlns:p14="http://schemas.microsoft.com/office/powerpoint/2010/main" val="2544406285"/>
+      </p:ext>
+    </p:extLst>
+  </p:cSld>
+  <p:clrMapOvr>
+    <a:masterClrMapping/>
+  </p:clrMapOvr>
+</p:sld>
+</file>
+
+<file path=ppt/slides/slide31.xml><?xml version="1.0" encoding="utf-8"?>
+<p:sld xmlns:a="http://schemas.openxmlformats.org/drawingml/2006/main" xmlns:r="http://schemas.openxmlformats.org/officeDocument/2006/relationships" xmlns:p="http://schemas.openxmlformats.org/presentationml/2006/main" show="0">
+  <p:cSld>
+    <p:spTree>
+      <p:nvGrpSpPr>
+        <p:cNvPr id="1" name=""/>
+        <p:cNvGrpSpPr/>
+        <p:nvPr/>
+      </p:nvGrpSpPr>
+      <p:grpSpPr>
+        <a:xfrm>
+          <a:off x="0" y="0"/>
+          <a:ext cx="0" cy="0"/>
+          <a:chOff x="0" y="0"/>
+          <a:chExt cx="0" cy="0"/>
+        </a:xfrm>
+      </p:grpSpPr>
+      <p:sp>
+        <p:nvSpPr>
           <p:cNvPr id="2" name="Title 1">
             <a:extLst>
               <a:ext uri="{FF2B5EF4-FFF2-40B4-BE49-F238E27FC236}">
@@ -7950,7 +8144,7 @@
 </p:sld>
 </file>
 
-<file path=ppt/slides/slide31.xml><?xml version="1.0" encoding="utf-8"?>
+<file path=ppt/slides/slide32.xml><?xml version="1.0" encoding="utf-8"?>
 <p:sld xmlns:a="http://schemas.openxmlformats.org/drawingml/2006/main" xmlns:r="http://schemas.openxmlformats.org/officeDocument/2006/relationships" xmlns:p="http://schemas.openxmlformats.org/presentationml/2006/main" show="0">
   <p:cSld>
     <p:spTree>
@@ -8078,7 +8272,7 @@
 </p:sld>
 </file>
 
-<file path=ppt/slides/slide32.xml><?xml version="1.0" encoding="utf-8"?>
+<file path=ppt/slides/slide33.xml><?xml version="1.0" encoding="utf-8"?>
 <p:sld xmlns:a="http://schemas.openxmlformats.org/drawingml/2006/main" xmlns:r="http://schemas.openxmlformats.org/officeDocument/2006/relationships" xmlns:p="http://schemas.openxmlformats.org/presentationml/2006/main" show="0">
   <p:cSld>
     <p:spTree>
@@ -8206,7 +8400,7 @@
 </p:sld>
 </file>
 
-<file path=ppt/slides/slide33.xml><?xml version="1.0" encoding="utf-8"?>
+<file path=ppt/slides/slide34.xml><?xml version="1.0" encoding="utf-8"?>
 <p:sld xmlns:a="http://schemas.openxmlformats.org/drawingml/2006/main" xmlns:r="http://schemas.openxmlformats.org/officeDocument/2006/relationships" xmlns:p="http://schemas.openxmlformats.org/presentationml/2006/main" show="0">
   <p:cSld>
     <p:spTree>
@@ -8334,7 +8528,7 @@
 </p:sld>
 </file>
 
-<file path=ppt/slides/slide34.xml><?xml version="1.0" encoding="utf-8"?>
+<file path=ppt/slides/slide35.xml><?xml version="1.0" encoding="utf-8"?>
 <p:sld xmlns:a="http://schemas.openxmlformats.org/drawingml/2006/main" xmlns:r="http://schemas.openxmlformats.org/officeDocument/2006/relationships" xmlns:p="http://schemas.openxmlformats.org/presentationml/2006/main" show="0">
   <p:cSld>
     <p:spTree>
@@ -8462,7 +8656,7 @@
 </p:sld>
 </file>
 
-<file path=ppt/slides/slide35.xml><?xml version="1.0" encoding="utf-8"?>
+<file path=ppt/slides/slide36.xml><?xml version="1.0" encoding="utf-8"?>
 <p:sld xmlns:a="http://schemas.openxmlformats.org/drawingml/2006/main" xmlns:r="http://schemas.openxmlformats.org/officeDocument/2006/relationships" xmlns:p="http://schemas.openxmlformats.org/presentationml/2006/main" show="0">
   <p:cSld>
     <p:spTree>

</xml_diff>